<commit_message>
atualizacao pptx 6 e 14.
</commit_message>
<xml_diff>
--- a/03-Slides/ETHAGT06/ETHAGT06-RAG-Agentico.pptx
+++ b/03-Slides/ETHAGT06/ETHAGT06-RAG-Agentico.pptx
@@ -11877,6 +11877,42 @@
         </p:nvSpPr>
         <p:spPr>
           <a:xfrm>
+            <a:off x="274320" y="6035040"/>
+            <a:ext cx="11612880" cy="320040"/>
+          </a:xfrm>
+          <a:prstGeom prst="rect">
+            <a:avLst/>
+          </a:prstGeom>
+          <a:noFill/>
+        </p:spPr>
+        <p:txBody>
+          <a:bodyPr wrap="square">
+            <a:spAutoFit/>
+          </a:bodyPr>
+          <a:lstStyle/>
+          <a:p>
+            <a:pPr algn="l">
+              <a:defRPr sz="900" b="0">
+                <a:solidFill>
+                  <a:srgbClr val="2980B9"/>
+                </a:solidFill>
+                <a:latin typeface="Segoe UI"/>
+              </a:defRPr>
+            </a:pPr>
+            <a:r>
+              <a:t>LLM = Large Language Model — Modelo de Linguagem de Grande Escala</a:t>
+            </a:r>
+          </a:p>
+        </p:txBody>
+      </p:sp>
+      <p:sp>
+        <p:nvSpPr>
+          <p:cNvPr id="8" name="TextBox 7"/>
+          <p:cNvSpPr txBox="1"/>
+          <p:nvPr/>
+        </p:nvSpPr>
+        <p:spPr>
+          <a:xfrm>
             <a:off x="274320" y="6400800"/>
             <a:ext cx="6400800" cy="365760"/>
           </a:xfrm>
@@ -11904,7 +11940,7 @@
       </p:sp>
       <p:sp>
         <p:nvSpPr>
-          <p:cNvPr id="8" name="TextBox 7"/>
+          <p:cNvPr id="9" name="TextBox 8"/>
           <p:cNvSpPr txBox="1"/>
           <p:nvPr/>
         </p:nvSpPr>
@@ -18629,6 +18665,42 @@
         </p:nvSpPr>
         <p:spPr>
           <a:xfrm>
+            <a:off x="274320" y="6035040"/>
+            <a:ext cx="11612880" cy="320040"/>
+          </a:xfrm>
+          <a:prstGeom prst="rect">
+            <a:avLst/>
+          </a:prstGeom>
+          <a:noFill/>
+        </p:spPr>
+        <p:txBody>
+          <a:bodyPr wrap="square">
+            <a:spAutoFit/>
+          </a:bodyPr>
+          <a:lstStyle/>
+          <a:p>
+            <a:pPr algn="l">
+              <a:defRPr sz="900" b="0">
+                <a:solidFill>
+                  <a:srgbClr val="2980B9"/>
+                </a:solidFill>
+                <a:latin typeface="Segoe UI"/>
+              </a:defRPr>
+            </a:pPr>
+            <a:r>
+              <a:t>AgentOps = Agent Operations — operacao e monitoramento de agentes em producao  ·  MCP = Model Context Protocol — Protocolo de Contexto de Modelo</a:t>
+            </a:r>
+          </a:p>
+        </p:txBody>
+      </p:sp>
+      <p:sp>
+        <p:nvSpPr>
+          <p:cNvPr id="8" name="TextBox 7"/>
+          <p:cNvSpPr txBox="1"/>
+          <p:nvPr/>
+        </p:nvSpPr>
+        <p:spPr>
+          <a:xfrm>
             <a:off x="274320" y="6400800"/>
             <a:ext cx="6400800" cy="365760"/>
           </a:xfrm>
@@ -18656,7 +18728,7 @@
       </p:sp>
       <p:sp>
         <p:nvSpPr>
-          <p:cNvPr id="8" name="TextBox 7"/>
+          <p:cNvPr id="9" name="TextBox 8"/>
           <p:cNvSpPr txBox="1"/>
           <p:nvPr/>
         </p:nvSpPr>
@@ -27165,6 +27237,42 @@
         </p:nvSpPr>
         <p:spPr>
           <a:xfrm>
+            <a:off x="274320" y="6035040"/>
+            <a:ext cx="11612880" cy="320040"/>
+          </a:xfrm>
+          <a:prstGeom prst="rect">
+            <a:avLst/>
+          </a:prstGeom>
+          <a:noFill/>
+        </p:spPr>
+        <p:txBody>
+          <a:bodyPr wrap="square">
+            <a:spAutoFit/>
+          </a:bodyPr>
+          <a:lstStyle/>
+          <a:p>
+            <a:pPr algn="l">
+              <a:defRPr sz="900" b="0">
+                <a:solidFill>
+                  <a:srgbClr val="2980B9"/>
+                </a:solidFill>
+                <a:latin typeface="Segoe UI"/>
+              </a:defRPr>
+            </a:pPr>
+            <a:r>
+              <a:t>ACI = Agent-Computer Interface — Interface Agente-Computador</a:t>
+            </a:r>
+          </a:p>
+        </p:txBody>
+      </p:sp>
+      <p:sp>
+        <p:nvSpPr>
+          <p:cNvPr id="8" name="TextBox 7"/>
+          <p:cNvSpPr txBox="1"/>
+          <p:nvPr/>
+        </p:nvSpPr>
+        <p:spPr>
+          <a:xfrm>
             <a:off x="274320" y="6400800"/>
             <a:ext cx="6400800" cy="365760"/>
           </a:xfrm>
@@ -27192,7 +27300,7 @@
       </p:sp>
       <p:sp>
         <p:nvSpPr>
-          <p:cNvPr id="8" name="TextBox 7"/>
+          <p:cNvPr id="9" name="TextBox 8"/>
           <p:cNvSpPr txBox="1"/>
           <p:nvPr/>
         </p:nvSpPr>
@@ -31134,6 +31242,42 @@
         </p:nvSpPr>
         <p:spPr>
           <a:xfrm>
+            <a:off x="274320" y="6035040"/>
+            <a:ext cx="11612880" cy="320040"/>
+          </a:xfrm>
+          <a:prstGeom prst="rect">
+            <a:avLst/>
+          </a:prstGeom>
+          <a:noFill/>
+        </p:spPr>
+        <p:txBody>
+          <a:bodyPr wrap="square">
+            <a:spAutoFit/>
+          </a:bodyPr>
+          <a:lstStyle/>
+          <a:p>
+            <a:pPr algn="l">
+              <a:defRPr sz="900" b="0">
+                <a:solidFill>
+                  <a:srgbClr val="2980B9"/>
+                </a:solidFill>
+                <a:latin typeface="Segoe UI"/>
+              </a:defRPr>
+            </a:pPr>
+            <a:r>
+              <a:t>BM25 = Best Matching 25 — algoritmo de ranking para busca textual</a:t>
+            </a:r>
+          </a:p>
+        </p:txBody>
+      </p:sp>
+      <p:sp>
+        <p:nvSpPr>
+          <p:cNvPr id="8" name="TextBox 7"/>
+          <p:cNvSpPr txBox="1"/>
+          <p:nvPr/>
+        </p:nvSpPr>
+        <p:spPr>
+          <a:xfrm>
             <a:off x="274320" y="6400800"/>
             <a:ext cx="6400800" cy="365760"/>
           </a:xfrm>
@@ -31161,7 +31305,7 @@
       </p:sp>
       <p:sp>
         <p:nvSpPr>
-          <p:cNvPr id="8" name="TextBox 7"/>
+          <p:cNvPr id="9" name="TextBox 8"/>
           <p:cNvSpPr txBox="1"/>
           <p:nvPr/>
         </p:nvSpPr>
@@ -36302,6 +36446,42 @@
         </p:nvSpPr>
         <p:spPr>
           <a:xfrm>
+            <a:off x="274320" y="6035040"/>
+            <a:ext cx="11612880" cy="320040"/>
+          </a:xfrm>
+          <a:prstGeom prst="rect">
+            <a:avLst/>
+          </a:prstGeom>
+          <a:noFill/>
+        </p:spPr>
+        <p:txBody>
+          <a:bodyPr wrap="square">
+            <a:spAutoFit/>
+          </a:bodyPr>
+          <a:lstStyle/>
+          <a:p>
+            <a:pPr algn="l">
+              <a:defRPr sz="900" b="0">
+                <a:solidFill>
+                  <a:srgbClr val="2980B9"/>
+                </a:solidFill>
+                <a:latin typeface="Segoe UI"/>
+              </a:defRPr>
+            </a:pPr>
+            <a:r>
+              <a:t>LLM-as-Judge = uso de um LLM como avaliador automatico de saidas de outro LLM</a:t>
+            </a:r>
+          </a:p>
+        </p:txBody>
+      </p:sp>
+      <p:sp>
+        <p:nvSpPr>
+          <p:cNvPr id="8" name="TextBox 7"/>
+          <p:cNvSpPr txBox="1"/>
+          <p:nvPr/>
+        </p:nvSpPr>
+        <p:spPr>
+          <a:xfrm>
             <a:off x="274320" y="6400800"/>
             <a:ext cx="6400800" cy="365760"/>
           </a:xfrm>
@@ -36329,7 +36509,7 @@
       </p:sp>
       <p:sp>
         <p:nvSpPr>
-          <p:cNvPr id="8" name="TextBox 7"/>
+          <p:cNvPr id="9" name="TextBox 8"/>
           <p:cNvSpPr txBox="1"/>
           <p:nvPr/>
         </p:nvSpPr>

</xml_diff>